<commit_message>
M6: fix duplicate info-card labels, convert Ide Chain to learn-grid, remove Rina persona, align PPT/PDF wording
</commit_message>
<xml_diff>
--- a/K2-Produktivitas/M06-Prompt-Chaining/K2-M06-Prompt-Chaining.pptx
+++ b/K2-Produktivitas/M06-Prompt-Chaining/K2-M06-Prompt-Chaining.pptx
@@ -2018,7 +2018,7 @@
                 <a:ea typeface="Helvetica" pitchFamily="34" charset="-122"/>
                 <a:cs typeface="Helvetica" pitchFamily="34" charset="-120"/>
               </a:rPr>
-              <a:t>•  Kalau satu prompt menghasilkan hasil yang dangkal atau generik</a:t>
+              <a:t>•  Kalau 1 prompt menghasilkan hasil yang dangkal atau generik</a:t>
             </a:r>
             <a:endParaRPr lang="en-US" sz="1300" dirty="0"/>
           </a:p>
@@ -2260,7 +2260,7 @@
                 <a:ea typeface="Helvetica" pitchFamily="34" charset="-122"/>
                 <a:cs typeface="Helvetica" pitchFamily="34" charset="-120"/>
               </a:rPr>
-              <a:t>RINA — CHAIN 4 STEP UNTUK KERJASAMA BANDUNG</a:t>
+              <a:t>CHAIN 4 STEP UNTUK KERJASAMA BANDUNG</a:t>
             </a:r>
             <a:endParaRPr lang="en-US" sz="1250" dirty="0"/>
           </a:p>
@@ -2552,7 +2552,7 @@
                 <a:ea typeface="Helvetica" pitchFamily="34" charset="-122"/>
                 <a:cs typeface="Helvetica" pitchFamily="34" charset="-120"/>
               </a:rPr>
-              <a:t>Struktur Proposal</a:t>
+              <a:t>Kerangka Proposal</a:t>
             </a:r>
             <a:endParaRPr lang="en-US" sz="1400" dirty="0"/>
           </a:p>
@@ -3415,7 +3415,7 @@
                 <a:ea typeface="Helvetica" pitchFamily="34" charset="-122"/>
                 <a:cs typeface="Helvetica" pitchFamily="34" charset="-120"/>
               </a:rPr>
-              <a:t>•  Konten bulanan: Riset trend → Kalender konten → Draft caption → Review</a:t>
+              <a:t>•  Konten Bulanan: Riset trend → Kalender konten → Draft caption → Review &amp; finalisasi</a:t>
             </a:r>
             <a:endParaRPr lang="en-US" sz="1300" dirty="0"/>
           </a:p>
@@ -3435,7 +3435,7 @@
                 <a:ea typeface="Helvetica" pitchFamily="34" charset="-122"/>
                 <a:cs typeface="Helvetica" pitchFamily="34" charset="-120"/>
               </a:rPr>
-              <a:t>•  Laporan performa: Analisis data → Insight → Narasi → Slide summary</a:t>
+              <a:t>•  Laporan Performa: Analisis data → Temukan insight → Buat narasi → Slide summary</a:t>
             </a:r>
             <a:endParaRPr lang="en-US" sz="1300" dirty="0"/>
           </a:p>

</xml_diff>

<commit_message>
M6: generalize intro, align HTML/PDF/PPT wording
</commit_message>
<xml_diff>
--- a/K2-Produktivitas/M06-Prompt-Chaining/K2-M06-Prompt-Chaining.pptx
+++ b/K2-Produktivitas/M06-Prompt-Chaining/K2-M06-Prompt-Chaining.pptx
@@ -1870,7 +1870,7 @@
         <p:spPr>
           <a:xfrm>
             <a:off x="548640" y="2517973"/>
-            <a:ext cx="11094415" cy="249367"/>
+            <a:ext cx="11094415" cy="498734"/>
           </a:xfrm>
           <a:prstGeom prst="rect">
             <a:avLst/>
@@ -1897,7 +1897,7 @@
                 <a:ea typeface="Helvetica" pitchFamily="34" charset="-122"/>
                 <a:cs typeface="Helvetica" pitchFamily="34" charset="-120"/>
               </a:rPr>
-              <a:t>Satu prompt menghasilkan output. Output itu jadi input untuk prompt berikutnya. Setiap step membangun di atas konteks yang sudah ada.</a:t>
+              <a:t>Prompt chaining adalah cara memecah tugas kompleks jadi beberapa step berurutan dalam satu chat yang sama — output dari satu prompt jadi input untuk prompt berikutnya, dan setiap step membangun di atas konteks yang sudah ada.</a:t>
             </a:r>
             <a:endParaRPr lang="en-US" sz="1300" dirty="0"/>
           </a:p>
@@ -1911,7 +1911,7 @@
         </p:nvSpPr>
         <p:spPr>
           <a:xfrm>
-            <a:off x="548640" y="3005084"/>
+            <a:off x="548640" y="3254451"/>
             <a:ext cx="11094415" cy="274320"/>
           </a:xfrm>
           <a:prstGeom prst="rect">
@@ -1950,7 +1950,7 @@
         </p:nvSpPr>
         <p:spPr>
           <a:xfrm>
-            <a:off x="548640" y="3334268"/>
+            <a:off x="548640" y="3583635"/>
             <a:ext cx="11094415" cy="876681"/>
           </a:xfrm>
           <a:prstGeom prst="rect">
@@ -1998,7 +1998,7 @@
                 <a:ea typeface="Helvetica" pitchFamily="34" charset="-122"/>
                 <a:cs typeface="Helvetica" pitchFamily="34" charset="-120"/>
               </a:rPr>
-              <a:t>•  Tugas yang punya tahapan logis — riset → draft → review → finalisasi</a:t>
+              <a:t>•  Tugas yang punya tahapan logis (riset → draft → review → finalisasi)</a:t>
             </a:r>
             <a:endParaRPr lang="en-US" sz="1300" dirty="0"/>
           </a:p>
@@ -2018,7 +2018,7 @@
                 <a:ea typeface="Helvetica" pitchFamily="34" charset="-122"/>
                 <a:cs typeface="Helvetica" pitchFamily="34" charset="-120"/>
               </a:rPr>
-              <a:t>•  Kalau 1 prompt menghasilkan hasil yang dangkal atau generik</a:t>
+              <a:t>•  Kalau 1 prompt langsung menghasilkan hasil yang dangkal dan generik</a:t>
             </a:r>
             <a:endParaRPr lang="en-US" sz="1300" dirty="0"/>
           </a:p>

</xml_diff>